<commit_message>
Record hosted premium closure evidence and remaining a11y fixes.
Keep Product Leadership review required: vendor invitation-to-submit is proven on 97d79ff, but axe, native PPTX visuals, and inbox delivery stay partial.

Co-authored-by: Cursor <cursoragent@cursor.com>
</commit_message>
<xml_diff>
--- a/docs/private-beta/hosted-ux-qa/premium-experience/reports/board-pptx.pptx
+++ b/docs/private-beta/hosted-ux-qa/premium-experience/reports/board-pptx.pptx
@@ -90,7 +90,7 @@
                   <a:srgbClr val="1E293B"/>
                 </a:solidFill>
               </a:rPr>
-              <a:t>• Elite Claims: 13 vendors, 1 high residual risk.</a:t>
+              <a:t>• Elite Claims: 14 vendors, 1 high residual risk.</a:t>
             </a:r>
           </a:p>
         </p:txBody>
@@ -120,7 +120,7 @@
                   <a:srgbClr val="1E293B"/>
                 </a:solidFill>
               </a:rPr>
-              <a:t>• 1 vendor currently sit in high or critical residual risk.</a:t>
+              <a:t>• 1 vendor currently sits in high or critical residual risk.</a:t>
             </a:r>
           </a:p>
         </p:txBody>
@@ -180,7 +180,37 @@
                   <a:srgbClr val="1E293B"/>
                 </a:solidFill>
               </a:rPr>
-              <a:t>• 1 remediation item are past the target date.</a:t>
+              <a:t>• 1 remediation item is past the target date.</a:t>
+            </a:r>
+          </a:p>
+        </p:txBody>
+      </p:sp>
+      <p:sp>
+        <p:nvSpPr>
+          <p:cNvPr id="7" name="t5"/>
+          <p:cNvSpPr txBox="1"/>
+          <p:nvPr/>
+        </p:nvSpPr>
+        <p:spPr>
+          <a:xfrm>
+            <a:off x="457200" y="2900000"/>
+            <a:ext cx="8229600" cy="457200"/>
+          </a:xfrm>
+          <a:prstGeom prst="rect">
+            <a:avLst/>
+          </a:prstGeom>
+        </p:spPr>
+        <p:txBody>
+          <a:bodyPr/>
+          <a:lstStyle/>
+          <a:p>
+            <a:r>
+              <a:rPr lang="en-US" sz="1600" b="0" dirty="0">
+                <a:solidFill>
+                  <a:srgbClr val="1E293B"/>
+                </a:solidFill>
+              </a:rPr>
+              <a:t>Supreme Governance Platform · Confidential — Board</a:t>
             </a:r>
           </a:p>
         </p:txBody>
@@ -360,6 +390,36 @@
           </a:p>
         </p:txBody>
       </p:sp>
+      <p:sp>
+        <p:nvSpPr>
+          <p:cNvPr id="7" name="t5"/>
+          <p:cNvSpPr txBox="1"/>
+          <p:nvPr/>
+        </p:nvSpPr>
+        <p:spPr>
+          <a:xfrm>
+            <a:off x="457200" y="2900000"/>
+            <a:ext cx="8229600" cy="457200"/>
+          </a:xfrm>
+          <a:prstGeom prst="rect">
+            <a:avLst/>
+          </a:prstGeom>
+        </p:spPr>
+        <p:txBody>
+          <a:bodyPr/>
+          <a:lstStyle/>
+          <a:p>
+            <a:r>
+              <a:rPr lang="en-US" sz="1600" b="0" dirty="0">
+                <a:solidFill>
+                  <a:srgbClr val="1E293B"/>
+                </a:solidFill>
+              </a:rPr>
+              <a:t>Supreme Governance Platform · Confidential — Board</a:t>
+            </a:r>
+          </a:p>
+        </p:txBody>
+      </p:sp>
     </p:spTree>
   </p:cSld>
   <p:clrMapOvr>
@@ -535,6 +595,36 @@
           </a:p>
         </p:txBody>
       </p:sp>
+      <p:sp>
+        <p:nvSpPr>
+          <p:cNvPr id="7" name="t5"/>
+          <p:cNvSpPr txBox="1"/>
+          <p:nvPr/>
+        </p:nvSpPr>
+        <p:spPr>
+          <a:xfrm>
+            <a:off x="457200" y="2900000"/>
+            <a:ext cx="8229600" cy="457200"/>
+          </a:xfrm>
+          <a:prstGeom prst="rect">
+            <a:avLst/>
+          </a:prstGeom>
+        </p:spPr>
+        <p:txBody>
+          <a:bodyPr/>
+          <a:lstStyle/>
+          <a:p>
+            <a:r>
+              <a:rPr lang="en-US" sz="1600" b="0" dirty="0">
+                <a:solidFill>
+                  <a:srgbClr val="1E293B"/>
+                </a:solidFill>
+              </a:rPr>
+              <a:t>Supreme Governance Platform · Confidential — Board</a:t>
+            </a:r>
+          </a:p>
+        </p:txBody>
+      </p:sp>
     </p:spTree>
   </p:cSld>
   <p:clrMapOvr>
@@ -735,7 +825,37 @@
                   <a:srgbClr val="1E293B"/>
                 </a:solidFill>
               </a:rPr>
-              <a:t>• Low 0–39: 9</a:t>
+              <a:t>• Low 0–39: 10</a:t>
+            </a:r>
+          </a:p>
+        </p:txBody>
+      </p:sp>
+      <p:sp>
+        <p:nvSpPr>
+          <p:cNvPr id="8" name="t6"/>
+          <p:cNvSpPr txBox="1"/>
+          <p:nvPr/>
+        </p:nvSpPr>
+        <p:spPr>
+          <a:xfrm>
+            <a:off x="457200" y="3320000"/>
+            <a:ext cx="8229600" cy="457200"/>
+          </a:xfrm>
+          <a:prstGeom prst="rect">
+            <a:avLst/>
+          </a:prstGeom>
+        </p:spPr>
+        <p:txBody>
+          <a:bodyPr/>
+          <a:lstStyle/>
+          <a:p>
+            <a:r>
+              <a:rPr lang="en-US" sz="1600" b="0" dirty="0">
+                <a:solidFill>
+                  <a:srgbClr val="1E293B"/>
+                </a:solidFill>
+              </a:rPr>
+              <a:t>Supreme Governance Platform · Confidential — Board</a:t>
             </a:r>
           </a:p>
         </p:txBody>
@@ -1000,6 +1120,36 @@
                   <a:srgbClr val="1E293B"/>
                 </a:solidFill>
               </a:rPr>
+              <a:t>• Phase C cross 1789360695: residual 31</a:t>
+            </a:r>
+          </a:p>
+        </p:txBody>
+      </p:sp>
+      <p:sp>
+        <p:nvSpPr>
+          <p:cNvPr id="10" name="t8"/>
+          <p:cNvSpPr txBox="1"/>
+          <p:nvPr/>
+        </p:nvSpPr>
+        <p:spPr>
+          <a:xfrm>
+            <a:off x="457200" y="4160000"/>
+            <a:ext cx="8229600" cy="457200"/>
+          </a:xfrm>
+          <a:prstGeom prst="rect">
+            <a:avLst/>
+          </a:prstGeom>
+        </p:spPr>
+        <p:txBody>
+          <a:bodyPr/>
+          <a:lstStyle/>
+          <a:p>
+            <a:r>
+              <a:rPr lang="en-US" sz="1600" b="0" dirty="0">
+                <a:solidFill>
+                  <a:srgbClr val="1E293B"/>
+                </a:solidFill>
+              </a:rPr>
               <a:t>• Phase C reject 1789361629: residual 31</a:t>
             </a:r>
           </a:p>
@@ -1007,30 +1157,30 @@
       </p:sp>
       <p:sp>
         <p:nvSpPr>
-          <p:cNvPr id="10" name="t8"/>
-          <p:cNvSpPr txBox="1"/>
-          <p:nvPr/>
-        </p:nvSpPr>
-        <p:spPr>
-          <a:xfrm>
-            <a:off x="457200" y="4160000"/>
-            <a:ext cx="8229600" cy="457200"/>
-          </a:xfrm>
-          <a:prstGeom prst="rect">
-            <a:avLst/>
-          </a:prstGeom>
-        </p:spPr>
-        <p:txBody>
-          <a:bodyPr/>
-          <a:lstStyle/>
-          <a:p>
-            <a:r>
-              <a:rPr lang="en-US" sz="1600" b="0" dirty="0">
-                <a:solidFill>
-                  <a:srgbClr val="1E293B"/>
-                </a:solidFill>
-              </a:rPr>
-              <a:t>• Phase B Portal 1789355266: residual 31</a:t>
+          <p:cNvPr id="11" name="t9"/>
+          <p:cNvSpPr txBox="1"/>
+          <p:nvPr/>
+        </p:nvSpPr>
+        <p:spPr>
+          <a:xfrm>
+            <a:off x="457200" y="4580000"/>
+            <a:ext cx="8229600" cy="457200"/>
+          </a:xfrm>
+          <a:prstGeom prst="rect">
+            <a:avLst/>
+          </a:prstGeom>
+        </p:spPr>
+        <p:txBody>
+          <a:bodyPr/>
+          <a:lstStyle/>
+          <a:p>
+            <a:r>
+              <a:rPr lang="en-US" sz="1600" b="0" dirty="0">
+                <a:solidFill>
+                  <a:srgbClr val="1E293B"/>
+                </a:solidFill>
+              </a:rPr>
+              <a:t>Supreme Governance Platform · Confidential — Board</a:t>
             </a:r>
           </a:p>
         </p:txBody>
@@ -1120,6 +1270,36 @@
           </a:p>
         </p:txBody>
       </p:sp>
+      <p:sp>
+        <p:nvSpPr>
+          <p:cNvPr id="4" name="t2"/>
+          <p:cNvSpPr txBox="1"/>
+          <p:nvPr/>
+        </p:nvSpPr>
+        <p:spPr>
+          <a:xfrm>
+            <a:off x="457200" y="1640000"/>
+            <a:ext cx="8229600" cy="457200"/>
+          </a:xfrm>
+          <a:prstGeom prst="rect">
+            <a:avLst/>
+          </a:prstGeom>
+        </p:spPr>
+        <p:txBody>
+          <a:bodyPr/>
+          <a:lstStyle/>
+          <a:p>
+            <a:r>
+              <a:rPr lang="en-US" sz="1600" b="0" dirty="0">
+                <a:solidFill>
+                  <a:srgbClr val="1E293B"/>
+                </a:solidFill>
+              </a:rPr>
+              <a:t>Supreme Governance Platform · Confidential — Board</a:t>
+            </a:r>
+          </a:p>
+        </p:txBody>
+      </p:sp>
     </p:spTree>
   </p:cSld>
   <p:clrMapOvr>
@@ -1415,6 +1595,36 @@
           </a:p>
         </p:txBody>
       </p:sp>
+      <p:sp>
+        <p:nvSpPr>
+          <p:cNvPr id="11" name="t9"/>
+          <p:cNvSpPr txBox="1"/>
+          <p:nvPr/>
+        </p:nvSpPr>
+        <p:spPr>
+          <a:xfrm>
+            <a:off x="457200" y="4580000"/>
+            <a:ext cx="8229600" cy="457200"/>
+          </a:xfrm>
+          <a:prstGeom prst="rect">
+            <a:avLst/>
+          </a:prstGeom>
+        </p:spPr>
+        <p:txBody>
+          <a:bodyPr/>
+          <a:lstStyle/>
+          <a:p>
+            <a:r>
+              <a:rPr lang="en-US" sz="1600" b="0" dirty="0">
+                <a:solidFill>
+                  <a:srgbClr val="1E293B"/>
+                </a:solidFill>
+              </a:rPr>
+              <a:t>Supreme Governance Platform · Confidential — Board</a:t>
+            </a:r>
+          </a:p>
+        </p:txBody>
+      </p:sp>
     </p:spTree>
   </p:cSld>
   <p:clrMapOvr>
@@ -1500,6 +1710,36 @@
           </a:p>
         </p:txBody>
       </p:sp>
+      <p:sp>
+        <p:nvSpPr>
+          <p:cNvPr id="4" name="t2"/>
+          <p:cNvSpPr txBox="1"/>
+          <p:nvPr/>
+        </p:nvSpPr>
+        <p:spPr>
+          <a:xfrm>
+            <a:off x="457200" y="1640000"/>
+            <a:ext cx="8229600" cy="457200"/>
+          </a:xfrm>
+          <a:prstGeom prst="rect">
+            <a:avLst/>
+          </a:prstGeom>
+        </p:spPr>
+        <p:txBody>
+          <a:bodyPr/>
+          <a:lstStyle/>
+          <a:p>
+            <a:r>
+              <a:rPr lang="en-US" sz="1600" b="0" dirty="0">
+                <a:solidFill>
+                  <a:srgbClr val="1E293B"/>
+                </a:solidFill>
+              </a:rPr>
+              <a:t>Supreme Governance Platform · Confidential — Board</a:t>
+            </a:r>
+          </a:p>
+        </p:txBody>
+      </p:sp>
     </p:spTree>
   </p:cSld>
   <p:clrMapOvr>
@@ -1615,6 +1855,36 @@
           </a:p>
         </p:txBody>
       </p:sp>
+      <p:sp>
+        <p:nvSpPr>
+          <p:cNvPr id="5" name="t3"/>
+          <p:cNvSpPr txBox="1"/>
+          <p:nvPr/>
+        </p:nvSpPr>
+        <p:spPr>
+          <a:xfrm>
+            <a:off x="457200" y="2060000"/>
+            <a:ext cx="8229600" cy="457200"/>
+          </a:xfrm>
+          <a:prstGeom prst="rect">
+            <a:avLst/>
+          </a:prstGeom>
+        </p:spPr>
+        <p:txBody>
+          <a:bodyPr/>
+          <a:lstStyle/>
+          <a:p>
+            <a:r>
+              <a:rPr lang="en-US" sz="1600" b="0" dirty="0">
+                <a:solidFill>
+                  <a:srgbClr val="1E293B"/>
+                </a:solidFill>
+              </a:rPr>
+              <a:t>Supreme Governance Platform · Confidential — Board</a:t>
+            </a:r>
+          </a:p>
+        </p:txBody>
+      </p:sp>
     </p:spTree>
   </p:cSld>
   <p:clrMapOvr>
@@ -1695,7 +1965,7 @@
                   <a:srgbClr val="1E293B"/>
                 </a:solidFill>
               </a:rPr>
-              <a:t>• REJECT residual 31</a:t>
+              <a:t>• Reject residual 31</a:t>
             </a:r>
           </a:p>
         </p:txBody>
@@ -1725,7 +1995,7 @@
                   <a:srgbClr val="1E293B"/>
                 </a:solidFill>
               </a:rPr>
-              <a:t>• APPROVE_WITH_CONDITIONS residual 58</a:t>
+              <a:t>• Approve With Conditions residual 58</a:t>
             </a:r>
           </a:p>
         </p:txBody>
@@ -1755,7 +2025,7 @@
                   <a:srgbClr val="1E293B"/>
                 </a:solidFill>
               </a:rPr>
-              <a:t>• RISK_ACCEPTED residual 58</a:t>
+              <a:t>• Risk Accepted residual 58</a:t>
             </a:r>
           </a:p>
         </p:txBody>
@@ -1785,7 +2055,7 @@
                   <a:srgbClr val="1E293B"/>
                 </a:solidFill>
               </a:rPr>
-              <a:t>• APPROVE_WITH_CONDITIONS residual 58</a:t>
+              <a:t>• Approve With Conditions residual 58</a:t>
             </a:r>
           </a:p>
         </p:txBody>
@@ -1815,7 +2085,37 @@
                   <a:srgbClr val="1E293B"/>
                 </a:solidFill>
               </a:rPr>
-              <a:t>• RISK_ACCEPTED residual 58</a:t>
+              <a:t>• Risk Accepted residual 58</a:t>
+            </a:r>
+          </a:p>
+        </p:txBody>
+      </p:sp>
+      <p:sp>
+        <p:nvSpPr>
+          <p:cNvPr id="8" name="t6"/>
+          <p:cNvSpPr txBox="1"/>
+          <p:nvPr/>
+        </p:nvSpPr>
+        <p:spPr>
+          <a:xfrm>
+            <a:off x="457200" y="3320000"/>
+            <a:ext cx="8229600" cy="457200"/>
+          </a:xfrm>
+          <a:prstGeom prst="rect">
+            <a:avLst/>
+          </a:prstGeom>
+        </p:spPr>
+        <p:txBody>
+          <a:bodyPr/>
+          <a:lstStyle/>
+          <a:p>
+            <a:r>
+              <a:rPr lang="en-US" sz="1600" b="0" dirty="0">
+                <a:solidFill>
+                  <a:srgbClr val="1E293B"/>
+                </a:solidFill>
+              </a:rPr>
+              <a:t>Supreme Governance Platform · Confidential — Board</a:t>
             </a:r>
           </a:p>
         </p:txBody>

</xml_diff>

<commit_message>
Record hosted premium final-verification evidence without declaring PASS.
Co-authored-by: Cursor <cursoragent@cursor.com>

#12 is recorded as Product Leadership accepted. Premium Platform remains PARTIAL pending their review of this hosted pack.
</commit_message>
<xml_diff>
--- a/docs/private-beta/hosted-ux-qa/premium-experience/reports/board-pptx.pptx
+++ b/docs/private-beta/hosted-ux-qa/premium-experience/reports/board-pptx.pptx
@@ -90,7 +90,7 @@
                   <a:srgbClr val="1E293B"/>
                 </a:solidFill>
               </a:rPr>
-              <a:t>• Elite Claims: 14 vendors, 1 high residual risk.</a:t>
+              <a:t>• Elite Claims: 19 vendors, 1 high residual risk.</a:t>
             </a:r>
           </a:p>
         </p:txBody>
@@ -150,7 +150,7 @@
                   <a:srgbClr val="1E293B"/>
                 </a:solidFill>
               </a:rPr>
-              <a:t>• 26 critical or high findings remain open.</a:t>
+              <a:t>• 36 critical or high findings remain open.</a:t>
             </a:r>
           </a:p>
         </p:txBody>
@@ -325,7 +325,7 @@
                   <a:srgbClr val="1E293B"/>
                 </a:solidFill>
               </a:rPr>
-              <a:t>• Remediate or formally accept 26 critical/high finding(s).</a:t>
+              <a:t>• Remediate or formally accept 36 critical/high finding(s).</a:t>
             </a:r>
           </a:p>
         </p:txBody>
@@ -560,7 +560,7 @@
                   <a:srgbClr val="1E293B"/>
                 </a:solidFill>
               </a:rPr>
-              <a:t>• Critical findings: 26</a:t>
+              <a:t>• Critical findings: 36</a:t>
             </a:r>
           </a:p>
         </p:txBody>
@@ -825,7 +825,7 @@
                   <a:srgbClr val="1E293B"/>
                 </a:solidFill>
               </a:rPr>
-              <a:t>• Low 0–39: 10</a:t>
+              <a:t>• Low 0–39: 15</a:t>
             </a:r>
           </a:p>
         </p:txBody>
@@ -1060,7 +1060,7 @@
                   <a:srgbClr val="1E293B"/>
                 </a:solidFill>
               </a:rPr>
-              <a:t>• Phase C cross 1789361629: residual 31</a:t>
+              <a:t>• Premium Vendor golden 1789427166: residual 31</a:t>
             </a:r>
           </a:p>
         </p:txBody>
@@ -1090,7 +1090,7 @@
                   <a:srgbClr val="1E293B"/>
                 </a:solidFill>
               </a:rPr>
-              <a:t>• Phase A Payroll 1789351850: residual 31</a:t>
+              <a:t>• Premium Vendor cross 1789427166: residual 31</a:t>
             </a:r>
           </a:p>
         </p:txBody>
@@ -1120,7 +1120,7 @@
                   <a:srgbClr val="1E293B"/>
                 </a:solidFill>
               </a:rPr>
-              <a:t>• Phase C cross 1789360695: residual 31</a:t>
+              <a:t>• Premium Vendor golden 1789427619: residual 31</a:t>
             </a:r>
           </a:p>
         </p:txBody>
@@ -1150,7 +1150,7 @@
                   <a:srgbClr val="1E293B"/>
                 </a:solidFill>
               </a:rPr>
-              <a:t>• Phase C reject 1789361629: residual 31</a:t>
+              <a:t>• Premium Vendor cross 1789427619: residual 31</a:t>
             </a:r>
           </a:p>
         </p:txBody>
@@ -1380,7 +1380,7 @@
                   <a:srgbClr val="1E293B"/>
                 </a:solidFill>
               </a:rPr>
-              <a:t>• Phase B Portal 1789355266: Response needs review: Are incidents reviewed after resolution?</a:t>
+              <a:t>• Premium Vendor golden 1789427619: Response needs review: Is there a vulnerability management process with defined remediation times?</a:t>
             </a:r>
           </a:p>
         </p:txBody>
@@ -1410,7 +1410,7 @@
                   <a:srgbClr val="1E293B"/>
                 </a:solidFill>
               </a:rPr>
-              <a:t>• Phase B Portal 1789355266: Response needs review: What is the committed customer-notification time after confirmed material incident?</a:t>
+              <a:t>• Premium Vendor golden 1789427619: Response needs review: Has an independent security assessment been completed in the last 12 months?</a:t>
             </a:r>
           </a:p>
         </p:txBody>
@@ -1440,7 +1440,7 @@
                   <a:srgbClr val="1E293B"/>
                 </a:solidFill>
               </a:rPr>
-              <a:t>• Phase B Portal 1789355266: Response needs review: Is a 24x7 contact path available for security incidents?</a:t>
+              <a:t>• Premium Vendor golden 1789427619: Response needs review: Is there a documented information security policy approved by management?</a:t>
             </a:r>
           </a:p>
         </p:txBody>
@@ -1470,7 +1470,7 @@
                   <a:srgbClr val="1E293B"/>
                 </a:solidFill>
               </a:rPr>
-              <a:t>• Phase B Portal 1789355266: Response needs review: Is there a documented incident-response plan for this service?</a:t>
+              <a:t>• Premium Vendor golden 1789427619: Response needs review: Are production systems patched on a defined schedule?</a:t>
             </a:r>
           </a:p>
         </p:txBody>
@@ -1500,7 +1500,7 @@
                   <a:srgbClr val="1E293B"/>
                 </a:solidFill>
               </a:rPr>
-              <a:t>• Phase B Portal 1789355266: Response needs review: Does the vendor host customer data in a cloud or SaaS environment?</a:t>
+              <a:t>• Premium Vendor golden 1789427619: Response needs review: Are security events logged and reviewed?</a:t>
             </a:r>
           </a:p>
         </p:txBody>
@@ -1530,7 +1530,7 @@
                   <a:srgbClr val="1E293B"/>
                 </a:solidFill>
               </a:rPr>
-              <a:t>• Phase B Portal 1789355266: Evidence still required: Are tenant isolation controls documented?</a:t>
+              <a:t>• Premium Vendor golden 1789427619: Response needs review: Is customer or confidential data encrypted in transit and at rest?</a:t>
             </a:r>
           </a:p>
         </p:txBody>
@@ -1560,7 +1560,7 @@
                   <a:srgbClr val="1E293B"/>
                 </a:solidFill>
               </a:rPr>
-              <a:t>• Phase B Portal 1789355266: Evidence still required: Is a current subprocessor list available?</a:t>
+              <a:t>• Premium Vendor golden 1789427619: Response needs review: Is access provisioned using least privilege?</a:t>
             </a:r>
           </a:p>
         </p:txBody>
@@ -1590,7 +1590,7 @@
                   <a:srgbClr val="1E293B"/>
                 </a:solidFill>
               </a:rPr>
-              <a:t>• Phase B Portal 1789355266: Response needs review: Does the vendor use subcontractors or subprocessors for this service?</a:t>
+              <a:t>• Premium Vendor golden 1789427619: Response needs review: Are privileged accounts reviewed at least quarterly?</a:t>
             </a:r>
           </a:p>
         </p:txBody>

</xml_diff>